<commit_message>
fix(vercel): configure outputDirectory, root build script, and interactive video links
</commit_message>
<xml_diff>
--- a/docs/Alfa-Konvejer-Umnyj-kreditnyj-kabinet-MSP.pptx
+++ b/docs/Alfa-Konvejer-Umnyj-kreditnyj-kabinet-MSP.pptx
@@ -3152,6 +3152,49 @@
           </a:prstGeom>
         </p:spPr>
       </p:pic>
+      <p:sp>
+        <p:nvSpPr>
+          <p:cNvPr id="4" name="Rectangle 3">
+            <a:hlinkClick r:id="rId6"/>
+          </p:cNvPr>
+          <p:cNvSpPr/>
+          <p:nvPr/>
+        </p:nvSpPr>
+        <p:spPr>
+          <a:xfrm>
+            <a:off x="6858000" y="1417320"/>
+            <a:ext cx="4892040" cy="3057753"/>
+          </a:xfrm>
+          <a:prstGeom prst="rect">
+            <a:avLst/>
+          </a:prstGeom>
+          <a:noFill/>
+          <a:ln>
+            <a:noFill/>
+          </a:ln>
+        </p:spPr>
+        <p:style>
+          <a:lnRef idx="1">
+            <a:schemeClr val="accent1"/>
+          </a:lnRef>
+          <a:fillRef idx="3">
+            <a:schemeClr val="accent1"/>
+          </a:fillRef>
+          <a:effectRef idx="2">
+            <a:schemeClr val="accent1"/>
+          </a:effectRef>
+          <a:fontRef idx="minor">
+            <a:schemeClr val="lt1"/>
+          </a:fontRef>
+        </p:style>
+        <p:txBody>
+          <a:bodyPr rtlCol="0" anchor="ctr"/>
+          <a:lstStyle/>
+          <a:p>
+            <a:pPr algn="ctr"/>
+          </a:p>
+        </p:txBody>
+      </p:sp>
     </p:spTree>
   </p:cSld>
   <p:clrMapOvr>
@@ -3338,7 +3381,50 @@
       </p:pic>
       <p:sp>
         <p:nvSpPr>
-          <p:cNvPr id="5" name="TextBox 4"/>
+          <p:cNvPr id="5" name="Rectangle 4">
+            <a:hlinkClick r:id="rId6"/>
+          </p:cNvPr>
+          <p:cNvSpPr/>
+          <p:nvPr/>
+        </p:nvSpPr>
+        <p:spPr>
+          <a:xfrm>
+            <a:off x="3261664" y="1927098"/>
+            <a:ext cx="5669280" cy="3543300"/>
+          </a:xfrm>
+          <a:prstGeom prst="rect">
+            <a:avLst/>
+          </a:prstGeom>
+          <a:noFill/>
+          <a:ln>
+            <a:noFill/>
+          </a:ln>
+        </p:spPr>
+        <p:style>
+          <a:lnRef idx="1">
+            <a:schemeClr val="accent1"/>
+          </a:lnRef>
+          <a:fillRef idx="3">
+            <a:schemeClr val="accent1"/>
+          </a:fillRef>
+          <a:effectRef idx="2">
+            <a:schemeClr val="accent1"/>
+          </a:effectRef>
+          <a:fontRef idx="minor">
+            <a:schemeClr val="lt1"/>
+          </a:fontRef>
+        </p:style>
+        <p:txBody>
+          <a:bodyPr rtlCol="0" anchor="ctr"/>
+          <a:lstStyle/>
+          <a:p>
+            <a:pPr algn="ctr"/>
+          </a:p>
+        </p:txBody>
+      </p:sp>
+      <p:sp>
+        <p:nvSpPr>
+          <p:cNvPr id="6" name="TextBox 5"/>
           <p:cNvSpPr txBox="1"/>
           <p:nvPr/>
         </p:nvSpPr>
@@ -3433,7 +3519,7 @@
       </p:sp>
       <p:sp>
         <p:nvSpPr>
-          <p:cNvPr id="6" name="TextBox 5"/>
+          <p:cNvPr id="7" name="TextBox 6"/>
           <p:cNvSpPr txBox="1"/>
           <p:nvPr/>
         </p:nvSpPr>

</xml_diff>